<commit_message>
Improve development tutorial and final presentation materials
</commit_message>
<xml_diff>
--- a/presentation/FastAPI_Task_Manager_Presentation_Final.pptx
+++ b/presentation/FastAPI_Task_Manager_Presentation_Final.pptx
@@ -16097,12 +16097,7 @@
         <p:nvPr/>
       </p:nvGrpSpPr>
       <p:grpSpPr>
-        <a:xfrm>
-          <a:off x="0" y="0"/>
-          <a:ext cx="0" cy="0"/>
-          <a:chOff x="0" y="0"/>
-          <a:chExt cx="0" cy="0"/>
-        </a:xfrm>
+        <a:xfrm/>
       </p:grpSpPr>
       <p:sp>
         <p:nvSpPr>
@@ -16293,7 +16288,7 @@
         <p:spPr>
           <a:xfrm>
             <a:off x="609600" y="762000"/>
-            <a:ext cx="10668000" cy="628650"/>
+            <a:ext cx="10972800" cy="609600"/>
           </a:xfrm>
           <a:prstGeom prst="rect">
             <a:avLst/>
@@ -16305,8 +16300,8 @@
           </a:ln>
         </p:spPr>
         <p:txBody>
-          <a:bodyPr wrap="square" lIns="0" tIns="0" rIns="0" bIns="0" anchor="t">
-            <a:normAutofit/>
+          <a:bodyPr lIns="0" tIns="0" rIns="0" bIns="0" anchor="t">
+            <a:normAutofit fontScale="100000"/>
           </a:bodyPr>
           <a:lstStyle>
             <a:defPPr algn="l">
@@ -16425,7 +16420,7 @@
                 <a:spcPct val="95000"/>
               </a:lnSpc>
               <a:buNone/>
-              <a:defRPr sz="2850" b="1" i="0">
+              <a:defRPr sz="3150" b="1" i="0">
                 <a:solidFill>
                   <a:srgbClr val="102333"/>
                 </a:solidFill>
@@ -16464,8 +16459,8 @@
         </p:nvSpPr>
         <p:spPr>
           <a:xfrm>
-            <a:off x="628650" y="1409700"/>
-            <a:ext cx="7810500" cy="628650"/>
+            <a:off x="609600" y="1562100"/>
+            <a:ext cx="10972800" cy="685800"/>
           </a:xfrm>
           <a:prstGeom prst="rect">
             <a:avLst/>
@@ -16477,12 +16472,12 @@
           </a:ln>
         </p:spPr>
         <p:txBody>
-          <a:bodyPr wrap="square" lIns="0" tIns="0" rIns="0" bIns="0" anchor="t">
-            <a:normAutofit/>
+          <a:bodyPr lIns="0" tIns="0" rIns="0" bIns="0" anchor="t">
+            <a:normAutofit fontScale="100000"/>
           </a:bodyPr>
           <a:lstStyle>
             <a:defPPr algn="l">
-              <a:defRPr sz="1725" b="0" i="0">
+              <a:defRPr sz="2100" b="0" i="0">
                 <a:solidFill>
                   <a:srgbClr val="536876"/>
                 </a:solidFill>
@@ -16597,7 +16592,7 @@
                 <a:spcPct val="100000"/>
               </a:lnSpc>
               <a:buNone/>
-              <a:defRPr sz="1350" b="0" i="0">
+              <a:defRPr sz="2100" b="0" i="0">
                 <a:solidFill>
                   <a:srgbClr val="536876"/>
                 </a:solidFill>
@@ -16607,7 +16602,7 @@
               </a:defRPr>
             </a:pPr>
             <a:r>
-              <a:rPr sz="1725" b="0" i="0">
+              <a:rPr sz="2100" b="0" i="0">
                 <a:solidFill>
                   <a:srgbClr val="536876"/>
                 </a:solidFill>
@@ -16615,7 +16610,34 @@
                 <a:ea typeface="Aptos"/>
                 <a:cs typeface="Aptos"/>
               </a:rPr>
-              <a:t>Each test uses a fresh in-memory repository. Eight passing results confirm that the main routes work as expected.</a:t>
+              <a:t>Each test uses a fresh in-memory repository.</a:t>
+            </a:r>
+          </a:p>
+          <a:p>
+            <a:pPr algn="l">
+              <a:lnSpc>
+                <a:spcPct val="100000"/>
+              </a:lnSpc>
+              <a:buNone/>
+              <a:defRPr sz="2100" b="0" i="0">
+                <a:solidFill>
+                  <a:srgbClr val="536876"/>
+                </a:solidFill>
+                <a:latin typeface="Aptos"/>
+                <a:ea typeface="Aptos"/>
+                <a:cs typeface="Aptos"/>
+              </a:defRPr>
+            </a:pPr>
+            <a:r>
+              <a:rPr sz="2100" b="0" i="0">
+                <a:solidFill>
+                  <a:srgbClr val="536876"/>
+                </a:solidFill>
+                <a:latin typeface="Aptos"/>
+                <a:ea typeface="Aptos"/>
+                <a:cs typeface="Aptos"/>
+              </a:rPr>
+              <a:t>Eight passing tests check the main routes and error responses.</a:t>
             </a:r>
           </a:p>
         </p:txBody>
@@ -17011,8 +17033,8 @@
         </p:nvSpPr>
         <p:spPr>
           <a:xfrm>
-            <a:off x="895350" y="2895600"/>
-            <a:ext cx="4210050" cy="1428750"/>
+            <a:off x="609600" y="2971800"/>
+            <a:ext cx="8286750" cy="428625"/>
           </a:xfrm>
           <a:prstGeom prst="rect">
             <a:avLst/>
@@ -17024,14 +17046,14 @@
           </a:ln>
         </p:spPr>
         <p:txBody>
-          <a:bodyPr wrap="square" lIns="0" tIns="0" rIns="0" bIns="0" anchor="t">
-            <a:normAutofit/>
+          <a:bodyPr lIns="0" tIns="0" rIns="0" bIns="0" anchor="t">
+            <a:normAutofit fontScale="100000"/>
           </a:bodyPr>
           <a:lstStyle>
             <a:defPPr algn="l">
-              <a:defRPr sz="1725" b="0" i="0">
-                <a:solidFill>
-                  <a:srgbClr val="8DE2BD"/>
+              <a:defRPr sz="2100" b="1" i="0">
+                <a:solidFill>
+                  <a:srgbClr val="102333"/>
                 </a:solidFill>
                 <a:latin typeface="Cascadia Mono"/>
                 <a:ea typeface="Cascadia Mono"/>
@@ -17144,15 +17166,23 @@
                 <a:spcPct val="130000"/>
               </a:lnSpc>
               <a:buNone/>
-              <a:defRPr sz="1725" b="0" i="0">
-                <a:solidFill>
-                  <a:srgbClr val="8DE2BD"/>
+              <a:defRPr sz="2100" b="1" i="0">
+                <a:solidFill>
+                  <a:srgbClr val="102333"/>
                 </a:solidFill>
                 <a:latin typeface="Cascadia Mono"/>
                 <a:ea typeface="Cascadia Mono"/>
                 <a:cs typeface="Cascadia Mono"/>
               </a:defRPr>
             </a:pPr>
+            <a:r>
+              <a:rPr sz="2100" b="1">
+                <a:solidFill>
+                  <a:srgbClr val="102333"/>
+                </a:solidFill>
+              </a:rPr>
+              <a:t>..\.venv\Scripts\python.exe -m pytest -q</a:t>
+            </a:r>
             <a:endParaRPr sz="1725" b="0" i="0">
               <a:solidFill>
                 <a:srgbClr val="8DE2BD"/>
@@ -17180,8 +17210,8 @@
         </p:nvSpPr>
         <p:spPr>
           <a:xfrm>
-            <a:off x="8763000" y="874820"/>
-            <a:ext cx="2266950" cy="1181100"/>
+            <a:off x="609600" y="4895850"/>
+            <a:ext cx="2571750" cy="1238250"/>
           </a:xfrm>
           <a:prstGeom prst="rect">
             <a:avLst/>
@@ -17194,6 +17224,13 @@
             <a:prstDash val="solid"/>
           </a:ln>
         </p:spPr>
+        <p:txBody>
+          <a:bodyPr/>
+          <a:lstStyle/>
+          <a:p>
+            <a:endParaRPr/>
+          </a:p>
+        </p:txBody>
       </p:sp>
       <p:sp>
         <p:nvSpPr>
@@ -17211,8 +17248,8 @@
         </p:nvSpPr>
         <p:spPr>
           <a:xfrm>
-            <a:off x="8953500" y="1030701"/>
-            <a:ext cx="1866900" cy="209550"/>
+            <a:off x="781050" y="5067300"/>
+            <a:ext cx="2228850" cy="285750"/>
           </a:xfrm>
           <a:prstGeom prst="rect">
             <a:avLst/>
@@ -17224,12 +17261,12 @@
           </a:ln>
         </p:spPr>
         <p:txBody>
-          <a:bodyPr wrap="square" lIns="0" tIns="0" rIns="0" bIns="0" anchor="t">
-            <a:normAutofit/>
+          <a:bodyPr lIns="0" tIns="0" rIns="0" bIns="0" anchor="t">
+            <a:normAutofit fontScale="100000"/>
           </a:bodyPr>
           <a:lstStyle>
             <a:defPPr algn="l">
-              <a:defRPr sz="1200" b="1" i="0">
+              <a:defRPr sz="1575" b="1" i="0">
                 <a:solidFill>
                   <a:srgbClr val="055A52"/>
                 </a:solidFill>
@@ -17344,7 +17381,7 @@
                 <a:spcPct val="100000"/>
               </a:lnSpc>
               <a:buNone/>
-              <a:defRPr sz="1050" b="1" i="0">
+              <a:defRPr sz="1575" b="1" i="0">
                 <a:solidFill>
                   <a:srgbClr val="055A52"/>
                 </a:solidFill>
@@ -17354,7 +17391,7 @@
               </a:defRPr>
             </a:pPr>
             <a:r>
-              <a:rPr sz="1200" b="1" i="0">
+              <a:rPr sz="1575" b="1" i="0">
                 <a:solidFill>
                   <a:srgbClr val="055A52"/>
                 </a:solidFill>
@@ -17383,8 +17420,8 @@
         </p:nvSpPr>
         <p:spPr>
           <a:xfrm>
-            <a:off x="8953500" y="1374181"/>
-            <a:ext cx="1866900" cy="495300"/>
+            <a:off x="781050" y="5448300"/>
+            <a:ext cx="2228850" cy="609600"/>
           </a:xfrm>
           <a:prstGeom prst="rect">
             <a:avLst/>
@@ -17396,12 +17433,12 @@
           </a:ln>
         </p:spPr>
         <p:txBody>
-          <a:bodyPr wrap="square" lIns="0" tIns="0" rIns="0" bIns="0" anchor="t">
-            <a:normAutofit fontScale="92120"/>
+          <a:bodyPr lIns="0" tIns="0" rIns="0" bIns="0" anchor="t">
+            <a:normAutofit fontScale="95238"/>
           </a:bodyPr>
           <a:lstStyle>
             <a:defPPr algn="l">
-              <a:defRPr sz="1575" b="1" i="0">
+              <a:defRPr sz="1875" b="1" i="0">
                 <a:solidFill>
                   <a:srgbClr val="102333"/>
                 </a:solidFill>
@@ -17516,7 +17553,7 @@
                 <a:spcPct val="112000"/>
               </a:lnSpc>
               <a:buNone/>
-              <a:defRPr sz="1275" b="1" i="0">
+              <a:defRPr sz="1875" b="1" i="0">
                 <a:solidFill>
                   <a:srgbClr val="102333"/>
                 </a:solidFill>
@@ -17526,7 +17563,7 @@
               </a:defRPr>
             </a:pPr>
             <a:r>
-              <a:rPr sz="1575" b="1" i="0">
+              <a:rPr sz="1875" b="1" i="0">
                 <a:solidFill>
                   <a:srgbClr val="102333"/>
                 </a:solidFill>
@@ -17534,7 +17571,34 @@
                 <a:ea typeface="Aptos"/>
                 <a:cs typeface="Aptos"/>
               </a:rPr>
-              <a:t>/docs and OpenAPI schema</a:t>
+              <a:t>/docs and</a:t>
+            </a:r>
+          </a:p>
+          <a:p>
+            <a:pPr algn="l">
+              <a:lnSpc>
+                <a:spcPct val="112000"/>
+              </a:lnSpc>
+              <a:buNone/>
+              <a:defRPr sz="1875" b="1" i="0">
+                <a:solidFill>
+                  <a:srgbClr val="102333"/>
+                </a:solidFill>
+                <a:latin typeface="Aptos"/>
+                <a:ea typeface="Aptos"/>
+                <a:cs typeface="Aptos"/>
+              </a:defRPr>
+            </a:pPr>
+            <a:r>
+              <a:rPr sz="1875" b="1" i="0">
+                <a:solidFill>
+                  <a:srgbClr val="102333"/>
+                </a:solidFill>
+                <a:latin typeface="Aptos"/>
+                <a:ea typeface="Aptos"/>
+                <a:cs typeface="Aptos"/>
+              </a:rPr>
+              <a:t>OpenAPI schema</a:t>
             </a:r>
           </a:p>
         </p:txBody>
@@ -17555,8 +17619,8 @@
         </p:nvSpPr>
         <p:spPr>
           <a:xfrm>
-            <a:off x="8763000" y="2266950"/>
-            <a:ext cx="2266950" cy="1181100"/>
+            <a:off x="3409950" y="4895850"/>
+            <a:ext cx="2571750" cy="1238250"/>
           </a:xfrm>
           <a:prstGeom prst="rect">
             <a:avLst/>
@@ -17586,8 +17650,8 @@
         </p:nvSpPr>
         <p:spPr>
           <a:xfrm>
-            <a:off x="8953500" y="2438400"/>
-            <a:ext cx="1866900" cy="209550"/>
+            <a:off x="3581400" y="5067300"/>
+            <a:ext cx="2228850" cy="285750"/>
           </a:xfrm>
           <a:prstGeom prst="rect">
             <a:avLst/>
@@ -17599,12 +17663,12 @@
           </a:ln>
         </p:spPr>
         <p:txBody>
-          <a:bodyPr wrap="square" lIns="0" tIns="0" rIns="0" bIns="0" anchor="t">
-            <a:normAutofit/>
+          <a:bodyPr lIns="0" tIns="0" rIns="0" bIns="0" anchor="t">
+            <a:normAutofit fontScale="100000"/>
           </a:bodyPr>
           <a:lstStyle>
             <a:defPPr algn="l">
-              <a:defRPr sz="1200" b="1" i="0">
+              <a:defRPr sz="1575" b="1" i="0">
                 <a:solidFill>
                   <a:srgbClr val="055A52"/>
                 </a:solidFill>
@@ -17719,7 +17783,7 @@
                 <a:spcPct val="100000"/>
               </a:lnSpc>
               <a:buNone/>
-              <a:defRPr sz="1050" b="1" i="0">
+              <a:defRPr sz="1575" b="1" i="0">
                 <a:solidFill>
                   <a:srgbClr val="055A52"/>
                 </a:solidFill>
@@ -17729,7 +17793,7 @@
               </a:defRPr>
             </a:pPr>
             <a:r>
-              <a:rPr sz="1200" b="1" i="0">
+              <a:rPr sz="1575" b="1" i="0">
                 <a:solidFill>
                   <a:srgbClr val="055A52"/>
                 </a:solidFill>
@@ -17758,8 +17822,8 @@
         </p:nvSpPr>
         <p:spPr>
           <a:xfrm>
-            <a:off x="8953500" y="2781300"/>
-            <a:ext cx="1866900" cy="495300"/>
+            <a:off x="3581400" y="5448300"/>
+            <a:ext cx="2228850" cy="609600"/>
           </a:xfrm>
           <a:prstGeom prst="rect">
             <a:avLst/>
@@ -17771,12 +17835,12 @@
           </a:ln>
         </p:spPr>
         <p:txBody>
-          <a:bodyPr wrap="square" lIns="0" tIns="0" rIns="0" bIns="0" anchor="t">
-            <a:normAutofit fontScale="92120"/>
+          <a:bodyPr lIns="0" tIns="0" rIns="0" bIns="0" anchor="t">
+            <a:normAutofit fontScale="95238"/>
           </a:bodyPr>
           <a:lstStyle>
             <a:defPPr algn="l">
-              <a:defRPr sz="1575" b="1" i="0">
+              <a:defRPr sz="1875" b="1" i="0">
                 <a:solidFill>
                   <a:srgbClr val="102333"/>
                 </a:solidFill>
@@ -17891,7 +17955,7 @@
                 <a:spcPct val="112000"/>
               </a:lnSpc>
               <a:buNone/>
-              <a:defRPr sz="1275" b="1" i="0">
+              <a:defRPr sz="1875" b="1" i="0">
                 <a:solidFill>
                   <a:srgbClr val="102333"/>
                 </a:solidFill>
@@ -17901,7 +17965,7 @@
               </a:defRPr>
             </a:pPr>
             <a:r>
-              <a:rPr sz="1575" b="1" i="0">
+              <a:rPr sz="1875" b="1" i="0">
                 <a:solidFill>
                   <a:srgbClr val="102333"/>
                 </a:solidFill>
@@ -17909,7 +17973,34 @@
                 <a:ea typeface="Aptos"/>
                 <a:cs typeface="Aptos"/>
               </a:rPr>
-              <a:t>Create, read, replace, delete</a:t>
+              <a:t>Create, read,</a:t>
+            </a:r>
+          </a:p>
+          <a:p>
+            <a:pPr algn="l">
+              <a:lnSpc>
+                <a:spcPct val="112000"/>
+              </a:lnSpc>
+              <a:buNone/>
+              <a:defRPr sz="1875" b="1" i="0">
+                <a:solidFill>
+                  <a:srgbClr val="102333"/>
+                </a:solidFill>
+                <a:latin typeface="Aptos"/>
+                <a:ea typeface="Aptos"/>
+                <a:cs typeface="Aptos"/>
+              </a:defRPr>
+            </a:pPr>
+            <a:r>
+              <a:rPr sz="1875" b="1" i="0">
+                <a:solidFill>
+                  <a:srgbClr val="102333"/>
+                </a:solidFill>
+                <a:latin typeface="Aptos"/>
+                <a:ea typeface="Aptos"/>
+                <a:cs typeface="Aptos"/>
+              </a:rPr>
+              <a:t>replace, delete</a:t>
             </a:r>
           </a:p>
         </p:txBody>
@@ -17930,8 +18021,8 @@
         </p:nvSpPr>
         <p:spPr>
           <a:xfrm>
-            <a:off x="8779046" y="5200650"/>
-            <a:ext cx="2266950" cy="1181100"/>
+            <a:off x="9010650" y="4895850"/>
+            <a:ext cx="2571750" cy="1238250"/>
           </a:xfrm>
           <a:prstGeom prst="rect">
             <a:avLst/>
@@ -17961,8 +18052,8 @@
         </p:nvSpPr>
         <p:spPr>
           <a:xfrm>
-            <a:off x="8953500" y="5372100"/>
-            <a:ext cx="1866900" cy="209550"/>
+            <a:off x="9182100" y="5067300"/>
+            <a:ext cx="2228850" cy="285750"/>
           </a:xfrm>
           <a:prstGeom prst="rect">
             <a:avLst/>
@@ -17974,12 +18065,12 @@
           </a:ln>
         </p:spPr>
         <p:txBody>
-          <a:bodyPr wrap="square" lIns="0" tIns="0" rIns="0" bIns="0" anchor="t">
-            <a:normAutofit/>
+          <a:bodyPr lIns="0" tIns="0" rIns="0" bIns="0" anchor="t">
+            <a:normAutofit fontScale="100000"/>
           </a:bodyPr>
           <a:lstStyle>
             <a:defPPr algn="l">
-              <a:defRPr sz="1200" b="1" i="0">
+              <a:defRPr sz="1575" b="1" i="0">
                 <a:solidFill>
                   <a:srgbClr val="EF765E"/>
                 </a:solidFill>
@@ -18094,7 +18185,7 @@
                 <a:spcPct val="100000"/>
               </a:lnSpc>
               <a:buNone/>
-              <a:defRPr sz="1050" b="1" i="0">
+              <a:defRPr sz="1575" b="1" i="0">
                 <a:solidFill>
                   <a:srgbClr val="EF765E"/>
                 </a:solidFill>
@@ -18104,7 +18195,7 @@
               </a:defRPr>
             </a:pPr>
             <a:r>
-              <a:rPr sz="1200" b="1" i="0">
+              <a:rPr sz="1575" b="1" i="0">
                 <a:solidFill>
                   <a:srgbClr val="EF765E"/>
                 </a:solidFill>
@@ -18133,8 +18224,8 @@
         </p:nvSpPr>
         <p:spPr>
           <a:xfrm>
-            <a:off x="8953500" y="5718283"/>
-            <a:ext cx="1866900" cy="495300"/>
+            <a:off x="9182100" y="5448300"/>
+            <a:ext cx="2228850" cy="609600"/>
           </a:xfrm>
           <a:prstGeom prst="rect">
             <a:avLst/>
@@ -18146,12 +18237,12 @@
           </a:ln>
         </p:spPr>
         <p:txBody>
-          <a:bodyPr wrap="square" lIns="0" tIns="0" rIns="0" bIns="0" anchor="t">
-            <a:normAutofit fontScale="98498"/>
+          <a:bodyPr lIns="0" tIns="0" rIns="0" bIns="0" anchor="t">
+            <a:normAutofit fontScale="95238"/>
           </a:bodyPr>
           <a:lstStyle>
             <a:defPPr algn="l">
-              <a:defRPr sz="1575" b="1" i="0">
+              <a:defRPr sz="1875" b="1" i="0">
                 <a:solidFill>
                   <a:srgbClr val="102333"/>
                 </a:solidFill>
@@ -18266,7 +18357,7 @@
                 <a:spcPct val="112000"/>
               </a:lnSpc>
               <a:buNone/>
-              <a:defRPr sz="1275" b="1" i="0">
+              <a:defRPr sz="1875" b="1" i="0">
                 <a:solidFill>
                   <a:srgbClr val="102333"/>
                 </a:solidFill>
@@ -18276,7 +18367,7 @@
               </a:defRPr>
             </a:pPr>
             <a:r>
-              <a:rPr sz="1575" b="1" i="0">
+              <a:rPr sz="1875" b="1" i="0">
                 <a:solidFill>
                   <a:srgbClr val="102333"/>
                 </a:solidFill>
@@ -18284,7 +18375,34 @@
                 <a:ea typeface="Aptos"/>
                 <a:cs typeface="Aptos"/>
               </a:rPr>
-              <a:t>404 and 422 responses</a:t>
+              <a:t>404 and 422</a:t>
+            </a:r>
+          </a:p>
+          <a:p>
+            <a:pPr algn="l">
+              <a:lnSpc>
+                <a:spcPct val="112000"/>
+              </a:lnSpc>
+              <a:buNone/>
+              <a:defRPr sz="1875" b="1" i="0">
+                <a:solidFill>
+                  <a:srgbClr val="102333"/>
+                </a:solidFill>
+                <a:latin typeface="Aptos"/>
+                <a:ea typeface="Aptos"/>
+                <a:cs typeface="Aptos"/>
+              </a:defRPr>
+            </a:pPr>
+            <a:r>
+              <a:rPr sz="1875" b="1" i="0">
+                <a:solidFill>
+                  <a:srgbClr val="102333"/>
+                </a:solidFill>
+                <a:latin typeface="Aptos"/>
+                <a:ea typeface="Aptos"/>
+                <a:cs typeface="Aptos"/>
+              </a:rPr>
+              <a:t>responses</a:t>
             </a:r>
           </a:p>
         </p:txBody>
@@ -18305,8 +18423,8 @@
         </p:nvSpPr>
         <p:spPr>
           <a:xfrm>
-            <a:off x="8763000" y="3733800"/>
-            <a:ext cx="2266950" cy="1181100"/>
+            <a:off x="6210300" y="4895850"/>
+            <a:ext cx="2571750" cy="1238250"/>
           </a:xfrm>
           <a:prstGeom prst="rect">
             <a:avLst/>
@@ -18336,8 +18454,8 @@
         </p:nvSpPr>
         <p:spPr>
           <a:xfrm>
-            <a:off x="8953500" y="3905250"/>
-            <a:ext cx="1866900" cy="209550"/>
+            <a:off x="6381750" y="5067300"/>
+            <a:ext cx="2228850" cy="285750"/>
           </a:xfrm>
           <a:prstGeom prst="rect">
             <a:avLst/>
@@ -18349,12 +18467,12 @@
           </a:ln>
         </p:spPr>
         <p:txBody>
-          <a:bodyPr wrap="square" lIns="0" tIns="0" rIns="0" bIns="0" anchor="t">
-            <a:normAutofit/>
+          <a:bodyPr lIns="0" tIns="0" rIns="0" bIns="0" anchor="t">
+            <a:normAutofit fontScale="100000"/>
           </a:bodyPr>
           <a:lstStyle>
             <a:defPPr algn="l">
-              <a:defRPr sz="1200" b="1" i="0">
+              <a:defRPr sz="1575" b="1" i="0">
                 <a:solidFill>
                   <a:srgbClr val="055A52"/>
                 </a:solidFill>
@@ -18469,7 +18587,7 @@
                 <a:spcPct val="100000"/>
               </a:lnSpc>
               <a:buNone/>
-              <a:defRPr sz="1050" b="1" i="0">
+              <a:defRPr sz="1575" b="1" i="0">
                 <a:solidFill>
                   <a:srgbClr val="055A52"/>
                 </a:solidFill>
@@ -18479,7 +18597,7 @@
               </a:defRPr>
             </a:pPr>
             <a:r>
-              <a:rPr sz="1200" b="1" i="0">
+              <a:rPr sz="1575" b="1" i="0">
                 <a:solidFill>
                   <a:srgbClr val="055A52"/>
                 </a:solidFill>
@@ -18508,8 +18626,8 @@
         </p:nvSpPr>
         <p:spPr>
           <a:xfrm>
-            <a:off x="8953500" y="4248150"/>
-            <a:ext cx="1866900" cy="495300"/>
+            <a:off x="6381750" y="5448300"/>
+            <a:ext cx="2228850" cy="609600"/>
           </a:xfrm>
           <a:prstGeom prst="rect">
             <a:avLst/>
@@ -18521,12 +18639,12 @@
           </a:ln>
         </p:spPr>
         <p:txBody>
-          <a:bodyPr wrap="square" lIns="0" tIns="0" rIns="0" bIns="0" anchor="t">
-            <a:normAutofit fontScale="92120"/>
+          <a:bodyPr lIns="0" tIns="0" rIns="0" bIns="0" anchor="t">
+            <a:normAutofit fontScale="95238"/>
           </a:bodyPr>
           <a:lstStyle>
             <a:defPPr algn="l">
-              <a:defRPr sz="1575" b="1" i="0">
+              <a:defRPr sz="1875" b="1" i="0">
                 <a:solidFill>
                   <a:srgbClr val="102333"/>
                 </a:solidFill>
@@ -18641,7 +18759,7 @@
                 <a:spcPct val="112000"/>
               </a:lnSpc>
               <a:buNone/>
-              <a:defRPr sz="1275" b="1" i="0">
+              <a:defRPr sz="1875" b="1" i="0">
                 <a:solidFill>
                   <a:srgbClr val="102333"/>
                 </a:solidFill>
@@ -18651,7 +18769,7 @@
               </a:defRPr>
             </a:pPr>
             <a:r>
-              <a:rPr sz="1575" b="1" i="0">
+              <a:rPr sz="1875" b="1" i="0">
                 <a:solidFill>
                   <a:srgbClr val="102333"/>
                 </a:solidFill>
@@ -18659,7 +18777,34 @@
                 <a:ea typeface="Aptos"/>
                 <a:cs typeface="Aptos"/>
               </a:rPr>
-              <a:t>Status and priority queries</a:t>
+              <a:t>Status and</a:t>
+            </a:r>
+          </a:p>
+          <a:p>
+            <a:pPr algn="l">
+              <a:lnSpc>
+                <a:spcPct val="112000"/>
+              </a:lnSpc>
+              <a:buNone/>
+              <a:defRPr sz="1875" b="1" i="0">
+                <a:solidFill>
+                  <a:srgbClr val="102333"/>
+                </a:solidFill>
+                <a:latin typeface="Aptos"/>
+                <a:ea typeface="Aptos"/>
+                <a:cs typeface="Aptos"/>
+              </a:defRPr>
+            </a:pPr>
+            <a:r>
+              <a:rPr sz="1875" b="1" i="0">
+                <a:solidFill>
+                  <a:srgbClr val="102333"/>
+                </a:solidFill>
+                <a:latin typeface="Aptos"/>
+                <a:ea typeface="Aptos"/>
+                <a:cs typeface="Aptos"/>
+              </a:rPr>
+              <a:t>priority queries</a:t>
             </a:r>
           </a:p>
         </p:txBody>
@@ -18680,8 +18825,8 @@
         </p:nvSpPr>
         <p:spPr>
           <a:xfrm>
-            <a:off x="685800" y="4857750"/>
-            <a:ext cx="7810500" cy="609600"/>
+            <a:off x="609600" y="3810000"/>
+            <a:ext cx="10972800" cy="742950"/>
           </a:xfrm>
           <a:prstGeom prst="rect">
             <a:avLst/>
@@ -18693,12 +18838,12 @@
           </a:ln>
         </p:spPr>
         <p:txBody>
-          <a:bodyPr wrap="square" lIns="0" tIns="0" rIns="0" bIns="0" anchor="t">
-            <a:normAutofit/>
+          <a:bodyPr lIns="0" tIns="0" rIns="0" bIns="0" anchor="t">
+            <a:normAutofit fontScale="100000"/>
           </a:bodyPr>
           <a:lstStyle>
             <a:defPPr algn="l">
-              <a:defRPr sz="1725" b="0" i="0">
+              <a:defRPr sz="2100" b="0" i="0">
                 <a:solidFill>
                   <a:srgbClr val="536876"/>
                 </a:solidFill>
@@ -18813,7 +18958,7 @@
                 <a:spcPct val="100000"/>
               </a:lnSpc>
               <a:buNone/>
-              <a:defRPr sz="1350" b="0" i="0">
+              <a:defRPr sz="2100" b="0" i="0">
                 <a:solidFill>
                   <a:srgbClr val="536876"/>
                 </a:solidFill>
@@ -18823,7 +18968,7 @@
               </a:defRPr>
             </a:pPr>
             <a:r>
-              <a:rPr sz="1725" b="0" i="0">
+              <a:rPr sz="2100" b="0" i="0">
                 <a:solidFill>
                   <a:srgbClr val="536876"/>
                 </a:solidFill>
@@ -18831,41 +18976,278 @@
                 <a:ea typeface="Aptos"/>
                 <a:cs typeface="Aptos"/>
               </a:rPr>
-              <a:t>TestClient sends normal HTTP-style requests without starting Uvicorn. A fresh repository keeps each test independent.</a:t>
+              <a:t>pytest runs the tests. TestClient sends HTTP-style requests</a:t>
+            </a:r>
+          </a:p>
+          <a:p>
+            <a:pPr algn="l">
+              <a:lnSpc>
+                <a:spcPct val="100000"/>
+              </a:lnSpc>
+              <a:buNone/>
+              <a:defRPr sz="2100" b="0" i="0">
+                <a:solidFill>
+                  <a:srgbClr val="536876"/>
+                </a:solidFill>
+                <a:latin typeface="Aptos"/>
+                <a:ea typeface="Aptos"/>
+                <a:cs typeface="Aptos"/>
+              </a:defRPr>
+            </a:pPr>
+            <a:r>
+              <a:rPr sz="2100" b="0" i="0">
+                <a:solidFill>
+                  <a:srgbClr val="536876"/>
+                </a:solidFill>
+                <a:latin typeface="Aptos"/>
+                <a:ea typeface="Aptos"/>
+                <a:cs typeface="Aptos"/>
+              </a:rPr>
+              <a:t>without starting Uvicorn.</a:t>
             </a:r>
           </a:p>
         </p:txBody>
       </p:sp>
-      <p:pic>
-        <p:nvPicPr>
-          <p:cNvPr id="26" name="图片 25">
+      <p:sp>
+        <p:nvSpPr>
+          <p:cNvPr id="25" name="Test command location">
             <a:extLst>
               <a:ext uri="{FF2B5EF4-FFF2-40B4-BE49-F238E27FC236}">
-                <a16:creationId xmlns:a16="http://schemas.microsoft.com/office/drawing/2014/main" id="{EC65061F-B9A5-48F0-BCD4-D2B88214B9D8}"/>
+                <a16:creationId xmlns:a16="http://schemas.microsoft.com/office/drawing/2014/main" id="{F4D16E3A-DEC5-4358-B137-1CF367A85963}"/>
               </a:ext>
             </a:extLst>
           </p:cNvPr>
-          <p:cNvPicPr>
-            <a:picLocks noChangeAspect="1"/>
-          </p:cNvPicPr>
+          <p:cNvSpPr>
+            <a:spLocks noGrp="1"/>
+          </p:cNvSpPr>
           <p:nvPr/>
-        </p:nvPicPr>
-        <p:blipFill>
-          <a:blip r:embed="rId3"/>
-          <a:stretch>
-            <a:fillRect/>
-          </a:stretch>
-        </p:blipFill>
+        </p:nvSpPr>
         <p:spPr>
           <a:xfrm>
-            <a:off x="384602" y="2266950"/>
-            <a:ext cx="8168848" cy="2257025"/>
+            <a:off x="609600" y="2571750"/>
+            <a:ext cx="8096250" cy="285750"/>
           </a:xfrm>
           <a:prstGeom prst="rect">
             <a:avLst/>
           </a:prstGeom>
+          <a:noFill/>
+          <a:ln w="0">
+            <a:noFill/>
+          </a:ln>
         </p:spPr>
-      </p:pic>
+        <p:txBody>
+          <a:bodyPr lIns="0" tIns="0" rIns="0" bIns="0" anchor="t"/>
+          <a:lstStyle>
+            <a:defPPr>
+              <a:defRPr sz="1725" b="1">
+                <a:solidFill>
+                  <a:srgbClr val="055A52"/>
+                </a:solidFill>
+              </a:defRPr>
+            </a:defPPr>
+            <a:lvl1pPr>
+              <a:defRPr sz="1725" b="1">
+                <a:solidFill>
+                  <a:srgbClr val="055A52"/>
+                </a:solidFill>
+              </a:defRPr>
+            </a:lvl1pPr>
+            <a:lvl2pPr>
+              <a:defRPr sz="1725" b="1">
+                <a:solidFill>
+                  <a:srgbClr val="055A52"/>
+                </a:solidFill>
+              </a:defRPr>
+            </a:lvl2pPr>
+            <a:lvl3pPr>
+              <a:defRPr sz="1725" b="1">
+                <a:solidFill>
+                  <a:srgbClr val="055A52"/>
+                </a:solidFill>
+              </a:defRPr>
+            </a:lvl3pPr>
+            <a:lvl4pPr>
+              <a:defRPr sz="1725" b="1">
+                <a:solidFill>
+                  <a:srgbClr val="055A52"/>
+                </a:solidFill>
+              </a:defRPr>
+            </a:lvl4pPr>
+            <a:lvl5pPr>
+              <a:defRPr sz="1725" b="1">
+                <a:solidFill>
+                  <a:srgbClr val="055A52"/>
+                </a:solidFill>
+              </a:defRPr>
+            </a:lvl5pPr>
+            <a:lvl6pPr>
+              <a:defRPr sz="1725" b="1">
+                <a:solidFill>
+                  <a:srgbClr val="055A52"/>
+                </a:solidFill>
+              </a:defRPr>
+            </a:lvl6pPr>
+            <a:lvl7pPr>
+              <a:defRPr sz="1725" b="1">
+                <a:solidFill>
+                  <a:srgbClr val="055A52"/>
+                </a:solidFill>
+              </a:defRPr>
+            </a:lvl7pPr>
+            <a:lvl8pPr>
+              <a:defRPr sz="1725" b="1">
+                <a:solidFill>
+                  <a:srgbClr val="055A52"/>
+                </a:solidFill>
+              </a:defRPr>
+            </a:lvl8pPr>
+            <a:lvl9pPr>
+              <a:defRPr sz="1725" b="1">
+                <a:solidFill>
+                  <a:srgbClr val="055A52"/>
+                </a:solidFill>
+              </a:defRPr>
+            </a:lvl9pPr>
+          </a:lstStyle>
+          <a:p>
+            <a:pPr>
+              <a:defRPr sz="1725" b="1">
+                <a:solidFill>
+                  <a:srgbClr val="055A52"/>
+                </a:solidFill>
+              </a:defRPr>
+            </a:pPr>
+            <a:r>
+              <a:rPr sz="1725" b="1">
+                <a:solidFill>
+                  <a:srgbClr val="055A52"/>
+                </a:solidFill>
+              </a:rPr>
+              <a:t>Run from fastapi-project</a:t>
+            </a:r>
+          </a:p>
+        </p:txBody>
+      </p:sp>
+      <p:sp>
+        <p:nvSpPr>
+          <p:cNvPr id="26" name="Verified test result">
+            <a:extLst>
+              <a:ext uri="{FF2B5EF4-FFF2-40B4-BE49-F238E27FC236}">
+                <a16:creationId xmlns:a16="http://schemas.microsoft.com/office/drawing/2014/main" id="{D93313B5-DCA3-4882-BFDD-CC9433F3C0C1}"/>
+              </a:ext>
+            </a:extLst>
+          </p:cNvPr>
+          <p:cNvSpPr>
+            <a:spLocks noGrp="1"/>
+          </p:cNvSpPr>
+          <p:nvPr/>
+        </p:nvSpPr>
+        <p:spPr>
+          <a:xfrm>
+            <a:off x="9163050" y="2686050"/>
+            <a:ext cx="2419350" cy="742950"/>
+          </a:xfrm>
+          <a:prstGeom prst="rect">
+            <a:avLst/>
+          </a:prstGeom>
+          <a:noFill/>
+          <a:ln w="0">
+            <a:noFill/>
+          </a:ln>
+        </p:spPr>
+        <p:txBody>
+          <a:bodyPr lIns="0" tIns="0" rIns="0" bIns="0" anchor="t"/>
+          <a:lstStyle>
+            <a:defPPr>
+              <a:defRPr sz="4050" b="1">
+                <a:solidFill>
+                  <a:srgbClr val="055A52"/>
+                </a:solidFill>
+              </a:defRPr>
+            </a:defPPr>
+            <a:lvl1pPr>
+              <a:defRPr sz="4050" b="1">
+                <a:solidFill>
+                  <a:srgbClr val="055A52"/>
+                </a:solidFill>
+              </a:defRPr>
+            </a:lvl1pPr>
+            <a:lvl2pPr>
+              <a:defRPr sz="4050" b="1">
+                <a:solidFill>
+                  <a:srgbClr val="055A52"/>
+                </a:solidFill>
+              </a:defRPr>
+            </a:lvl2pPr>
+            <a:lvl3pPr>
+              <a:defRPr sz="4050" b="1">
+                <a:solidFill>
+                  <a:srgbClr val="055A52"/>
+                </a:solidFill>
+              </a:defRPr>
+            </a:lvl3pPr>
+            <a:lvl4pPr>
+              <a:defRPr sz="4050" b="1">
+                <a:solidFill>
+                  <a:srgbClr val="055A52"/>
+                </a:solidFill>
+              </a:defRPr>
+            </a:lvl4pPr>
+            <a:lvl5pPr>
+              <a:defRPr sz="4050" b="1">
+                <a:solidFill>
+                  <a:srgbClr val="055A52"/>
+                </a:solidFill>
+              </a:defRPr>
+            </a:lvl5pPr>
+            <a:lvl6pPr>
+              <a:defRPr sz="4050" b="1">
+                <a:solidFill>
+                  <a:srgbClr val="055A52"/>
+                </a:solidFill>
+              </a:defRPr>
+            </a:lvl6pPr>
+            <a:lvl7pPr>
+              <a:defRPr sz="4050" b="1">
+                <a:solidFill>
+                  <a:srgbClr val="055A52"/>
+                </a:solidFill>
+              </a:defRPr>
+            </a:lvl7pPr>
+            <a:lvl8pPr>
+              <a:defRPr sz="4050" b="1">
+                <a:solidFill>
+                  <a:srgbClr val="055A52"/>
+                </a:solidFill>
+              </a:defRPr>
+            </a:lvl8pPr>
+            <a:lvl9pPr>
+              <a:defRPr sz="4050" b="1">
+                <a:solidFill>
+                  <a:srgbClr val="055A52"/>
+                </a:solidFill>
+              </a:defRPr>
+            </a:lvl9pPr>
+          </a:lstStyle>
+          <a:p>
+            <a:pPr>
+              <a:defRPr sz="4050" b="1">
+                <a:solidFill>
+                  <a:srgbClr val="055A52"/>
+                </a:solidFill>
+              </a:defRPr>
+            </a:pPr>
+            <a:r>
+              <a:rPr sz="4050" b="1">
+                <a:solidFill>
+                  <a:srgbClr val="055A52"/>
+                </a:solidFill>
+              </a:rPr>
+              <a:t>8 passed</a:t>
+            </a:r>
+          </a:p>
+        </p:txBody>
+      </p:sp>
     </p:spTree>
     <p:extLst>
       <p:ext uri="{BB962C8B-B14F-4D97-AF65-F5344CB8AC3E}">

</xml_diff>